<commit_message>
Update gitbook 2025-10-24 19:38:07
</commit_message>
<xml_diff>
--- a/Heist/EscapeRoomMap.pptx
+++ b/Heist/EscapeRoomMap.pptx
@@ -124,6 +124,11 @@
       </a:defRPr>
     </a:lvl9pPr>
   </p:defaultTextStyle>
+  <p:extLst>
+    <p:ext uri="{EFAFB233-063F-42B5-8137-9DF3F51BA10A}">
+      <p15:sldGuideLst xmlns:p15="http://schemas.microsoft.com/office/powerpoint/2012/main"/>
+    </p:ext>
+  </p:extLst>
 </p:presentation>
 </file>
 
@@ -7948,8 +7953,16 @@
               <a:rPr lang="en-US" b="1" dirty="0">
                 <a:latin typeface="Inter" panose="02000503000000020004" pitchFamily="2" charset="0"/>
                 <a:ea typeface="Inter" panose="02000503000000020004" pitchFamily="2" charset="0"/>
-              </a:rPr>
-              <a:t>GREEN HINT:</a:t>
+                <a:hlinkClick r:id="rId2" action="ppaction://hlinksldjump"/>
+              </a:rPr>
+              <a:t>GREEN HINT</a:t>
+            </a:r>
+            <a:r>
+              <a:rPr lang="en-US" b="1" dirty="0">
+                <a:latin typeface="Inter" panose="02000503000000020004" pitchFamily="2" charset="0"/>
+                <a:ea typeface="Inter" panose="02000503000000020004" pitchFamily="2" charset="0"/>
+              </a:rPr>
+              <a:t>:</a:t>
             </a:r>
             <a:r>
               <a:rPr lang="en-US" dirty="0">
@@ -7964,8 +7977,16 @@
               <a:rPr lang="en-US" b="1" dirty="0">
                 <a:latin typeface="Inter" panose="02000503000000020004" pitchFamily="2" charset="0"/>
                 <a:ea typeface="Inter" panose="02000503000000020004" pitchFamily="2" charset="0"/>
-              </a:rPr>
-              <a:t>BLUE HINT:</a:t>
+                <a:hlinkClick r:id="rId3" action="ppaction://hlinksldjump"/>
+              </a:rPr>
+              <a:t>BLUE HINT</a:t>
+            </a:r>
+            <a:r>
+              <a:rPr lang="en-US" b="1" dirty="0">
+                <a:latin typeface="Inter" panose="02000503000000020004" pitchFamily="2" charset="0"/>
+                <a:ea typeface="Inter" panose="02000503000000020004" pitchFamily="2" charset="0"/>
+              </a:rPr>
+              <a:t>:</a:t>
             </a:r>
             <a:r>
               <a:rPr lang="en-US" dirty="0">
@@ -7980,8 +8001,16 @@
               <a:rPr lang="en-US" b="1" dirty="0">
                 <a:latin typeface="Inter" panose="02000503000000020004" pitchFamily="2" charset="0"/>
                 <a:ea typeface="Inter" panose="02000503000000020004" pitchFamily="2" charset="0"/>
-              </a:rPr>
-              <a:t>CRYPTEX HINT 1:</a:t>
+                <a:hlinkClick r:id="rId4" action="ppaction://hlinksldjump"/>
+              </a:rPr>
+              <a:t>CRYPTEX HINT 1</a:t>
+            </a:r>
+            <a:r>
+              <a:rPr lang="en-US" b="1" dirty="0">
+                <a:latin typeface="Inter" panose="02000503000000020004" pitchFamily="2" charset="0"/>
+                <a:ea typeface="Inter" panose="02000503000000020004" pitchFamily="2" charset="0"/>
+              </a:rPr>
+              <a:t>:</a:t>
             </a:r>
             <a:r>
               <a:rPr lang="en-US" dirty="0">
@@ -7996,8 +8025,16 @@
               <a:rPr lang="en-US" b="1" dirty="0">
                 <a:latin typeface="Inter" panose="02000503000000020004" pitchFamily="2" charset="0"/>
                 <a:ea typeface="Inter" panose="02000503000000020004" pitchFamily="2" charset="0"/>
-              </a:rPr>
-              <a:t>CRYPTEX HINT 2:</a:t>
+                <a:hlinkClick r:id="rId4" action="ppaction://hlinksldjump"/>
+              </a:rPr>
+              <a:t>CRYPTEX HINT 2</a:t>
+            </a:r>
+            <a:r>
+              <a:rPr lang="en-US" b="1" dirty="0">
+                <a:latin typeface="Inter" panose="02000503000000020004" pitchFamily="2" charset="0"/>
+                <a:ea typeface="Inter" panose="02000503000000020004" pitchFamily="2" charset="0"/>
+              </a:rPr>
+              <a:t>:</a:t>
             </a:r>
             <a:r>
               <a:rPr lang="en-US" dirty="0">
@@ -8012,8 +8049,16 @@
               <a:rPr lang="en-US" b="1" dirty="0">
                 <a:latin typeface="Inter" panose="02000503000000020004" pitchFamily="2" charset="0"/>
                 <a:ea typeface="Inter" panose="02000503000000020004" pitchFamily="2" charset="0"/>
-              </a:rPr>
-              <a:t>CRYPTEX HINT 3:</a:t>
+                <a:hlinkClick r:id="rId5" action="ppaction://hlinksldjump"/>
+              </a:rPr>
+              <a:t>CRYPTEX HINT 3</a:t>
+            </a:r>
+            <a:r>
+              <a:rPr lang="en-US" b="1" dirty="0">
+                <a:latin typeface="Inter" panose="02000503000000020004" pitchFamily="2" charset="0"/>
+                <a:ea typeface="Inter" panose="02000503000000020004" pitchFamily="2" charset="0"/>
+              </a:rPr>
+              <a:t>:</a:t>
             </a:r>
             <a:r>
               <a:rPr lang="en-US" dirty="0">
@@ -8044,8 +8089,16 @@
               <a:rPr lang="en-US" b="1" dirty="0">
                 <a:latin typeface="Inter" panose="02000503000000020004" pitchFamily="2" charset="0"/>
                 <a:ea typeface="Inter" panose="02000503000000020004" pitchFamily="2" charset="0"/>
-              </a:rPr>
-              <a:t>KEY-AT-LARGE HINT: </a:t>
+                <a:hlinkClick r:id="rId6" action="ppaction://hlinksldjump"/>
+              </a:rPr>
+              <a:t>KEY-AT-LARGE HINT</a:t>
+            </a:r>
+            <a:r>
+              <a:rPr lang="en-US" b="1" dirty="0">
+                <a:latin typeface="Inter" panose="02000503000000020004" pitchFamily="2" charset="0"/>
+                <a:ea typeface="Inter" panose="02000503000000020004" pitchFamily="2" charset="0"/>
+              </a:rPr>
+              <a:t>: </a:t>
             </a:r>
             <a:r>
               <a:rPr lang="en-US" dirty="0">
@@ -8076,8 +8129,16 @@
               <a:rPr lang="en-US" b="1" dirty="0">
                 <a:latin typeface="Inter" panose="02000503000000020004" pitchFamily="2" charset="0"/>
                 <a:ea typeface="Inter" panose="02000503000000020004" pitchFamily="2" charset="0"/>
-              </a:rPr>
-              <a:t>CHOSEN ONE'S KEY HINT: </a:t>
+                <a:hlinkClick r:id="rId4" action="ppaction://hlinksldjump"/>
+              </a:rPr>
+              <a:t>CHOSEN ONE'S KEY HINT</a:t>
+            </a:r>
+            <a:r>
+              <a:rPr lang="en-US" b="1" dirty="0">
+                <a:latin typeface="Inter" panose="02000503000000020004" pitchFamily="2" charset="0"/>
+                <a:ea typeface="Inter" panose="02000503000000020004" pitchFamily="2" charset="0"/>
+              </a:rPr>
+              <a:t>: </a:t>
             </a:r>
             <a:r>
               <a:rPr lang="en-US" dirty="0">
@@ -8092,8 +8153,16 @@
               <a:rPr lang="en-US" b="1" dirty="0">
                 <a:latin typeface="Inter" panose="02000503000000020004" pitchFamily="2" charset="0"/>
                 <a:ea typeface="Inter" panose="02000503000000020004" pitchFamily="2" charset="0"/>
-              </a:rPr>
-              <a:t>KEY D HINT 1: </a:t>
+                <a:hlinkClick r:id="rId5" action="ppaction://hlinksldjump"/>
+              </a:rPr>
+              <a:t>KEY D HINT 1</a:t>
+            </a:r>
+            <a:r>
+              <a:rPr lang="en-US" b="1" dirty="0">
+                <a:latin typeface="Inter" panose="02000503000000020004" pitchFamily="2" charset="0"/>
+                <a:ea typeface="Inter" panose="02000503000000020004" pitchFamily="2" charset="0"/>
+              </a:rPr>
+              <a:t>: </a:t>
             </a:r>
             <a:r>
               <a:rPr lang="en-US" dirty="0">
@@ -8108,8 +8177,16 @@
               <a:rPr lang="en-US" b="1" dirty="0">
                 <a:latin typeface="Inter" panose="02000503000000020004" pitchFamily="2" charset="0"/>
                 <a:ea typeface="Inter" panose="02000503000000020004" pitchFamily="2" charset="0"/>
-              </a:rPr>
-              <a:t>KEY D HINT 2: </a:t>
+                <a:hlinkClick r:id="rId5" action="ppaction://hlinksldjump"/>
+              </a:rPr>
+              <a:t>KEY D HINT 2</a:t>
+            </a:r>
+            <a:r>
+              <a:rPr lang="en-US" b="1" dirty="0">
+                <a:latin typeface="Inter" panose="02000503000000020004" pitchFamily="2" charset="0"/>
+                <a:ea typeface="Inter" panose="02000503000000020004" pitchFamily="2" charset="0"/>
+              </a:rPr>
+              <a:t>: </a:t>
             </a:r>
             <a:r>
               <a:rPr lang="en-US" dirty="0">
@@ -8124,8 +8201,16 @@
               <a:rPr lang="en-US" b="1" dirty="0">
                 <a:latin typeface="Inter" panose="02000503000000020004" pitchFamily="2" charset="0"/>
                 <a:ea typeface="Inter" panose="02000503000000020004" pitchFamily="2" charset="0"/>
-              </a:rPr>
-              <a:t>KEY D HINT 3:</a:t>
+                <a:hlinkClick r:id="rId5" action="ppaction://hlinksldjump"/>
+              </a:rPr>
+              <a:t>KEY D HINT 3</a:t>
+            </a:r>
+            <a:r>
+              <a:rPr lang="en-US" b="1" dirty="0">
+                <a:latin typeface="Inter" panose="02000503000000020004" pitchFamily="2" charset="0"/>
+                <a:ea typeface="Inter" panose="02000503000000020004" pitchFamily="2" charset="0"/>
+              </a:rPr>
+              <a:t>:</a:t>
             </a:r>
             <a:r>
               <a:rPr lang="en-US" dirty="0">
@@ -8140,8 +8225,16 @@
               <a:rPr lang="en-US" b="1" dirty="0">
                 <a:latin typeface="Inter" panose="02000503000000020004" pitchFamily="2" charset="0"/>
                 <a:ea typeface="Inter" panose="02000503000000020004" pitchFamily="2" charset="0"/>
-              </a:rPr>
-              <a:t>KEY D HINT 4:</a:t>
+                <a:hlinkClick r:id="rId4" action="ppaction://hlinksldjump"/>
+              </a:rPr>
+              <a:t>KEY D HINT 4</a:t>
+            </a:r>
+            <a:r>
+              <a:rPr lang="en-US" b="1" dirty="0">
+                <a:latin typeface="Inter" panose="02000503000000020004" pitchFamily="2" charset="0"/>
+                <a:ea typeface="Inter" panose="02000503000000020004" pitchFamily="2" charset="0"/>
+              </a:rPr>
+              <a:t>:</a:t>
             </a:r>
             <a:r>
               <a:rPr lang="en-US" dirty="0">
@@ -8156,8 +8249,16 @@
               <a:rPr lang="en-US" b="1" dirty="0">
                 <a:latin typeface="Inter" panose="02000503000000020004" pitchFamily="2" charset="0"/>
                 <a:ea typeface="Inter" panose="02000503000000020004" pitchFamily="2" charset="0"/>
-              </a:rPr>
-              <a:t>KEY D HINT 5:</a:t>
+                <a:hlinkClick r:id="rId4" action="ppaction://hlinksldjump"/>
+              </a:rPr>
+              <a:t>KEY D HINT 5</a:t>
+            </a:r>
+            <a:r>
+              <a:rPr lang="en-US" b="1" dirty="0">
+                <a:latin typeface="Inter" panose="02000503000000020004" pitchFamily="2" charset="0"/>
+                <a:ea typeface="Inter" panose="02000503000000020004" pitchFamily="2" charset="0"/>
+              </a:rPr>
+              <a:t>:</a:t>
             </a:r>
             <a:r>
               <a:rPr lang="en-US" dirty="0">
@@ -22582,7 +22683,7 @@
                 <a:latin typeface="Inter" panose="02000503000000020004" pitchFamily="2" charset="0"/>
                 <a:ea typeface="Inter" panose="02000503000000020004" pitchFamily="2" charset="0"/>
               </a:rPr>
-              <a:t>FROM GREEN SHARPIE</a:t>
+              <a:t>GREEN SHARPIE</a:t>
             </a:r>
           </a:p>
         </p:txBody>

</xml_diff>

<commit_message>
Update gitbook 2025-10-28 22:10:36
</commit_message>
<xml_diff>
--- a/Heist/EscapeRoomMap.pptx
+++ b/Heist/EscapeRoomMap.pptx
@@ -214,7 +214,7 @@
           <a:p>
             <a:fld id="{39EF2ED4-5B67-4D6C-8F53-519A476C78EC}" type="datetimeFigureOut">
               <a:rPr lang="en-US" smtClean="0"/>
-              <a:t>10/24/2025</a:t>
+              <a:t>10/28/2025</a:t>
             </a:fld>
             <a:endParaRPr lang="en-US"/>
           </a:p>
@@ -820,7 +820,7 @@
           <a:p>
             <a:fld id="{A499D77D-9F63-495D-952D-8FFE08F30C8F}" type="datetimeFigureOut">
               <a:rPr lang="en-US" smtClean="0"/>
-              <a:t>10/24/2025</a:t>
+              <a:t>10/28/2025</a:t>
             </a:fld>
             <a:endParaRPr lang="en-US"/>
           </a:p>
@@ -1018,7 +1018,7 @@
           <a:p>
             <a:fld id="{A499D77D-9F63-495D-952D-8FFE08F30C8F}" type="datetimeFigureOut">
               <a:rPr lang="en-US" smtClean="0"/>
-              <a:t>10/24/2025</a:t>
+              <a:t>10/28/2025</a:t>
             </a:fld>
             <a:endParaRPr lang="en-US"/>
           </a:p>
@@ -1226,7 +1226,7 @@
           <a:p>
             <a:fld id="{A499D77D-9F63-495D-952D-8FFE08F30C8F}" type="datetimeFigureOut">
               <a:rPr lang="en-US" smtClean="0"/>
-              <a:t>10/24/2025</a:t>
+              <a:t>10/28/2025</a:t>
             </a:fld>
             <a:endParaRPr lang="en-US"/>
           </a:p>
@@ -1424,7 +1424,7 @@
           <a:p>
             <a:fld id="{A499D77D-9F63-495D-952D-8FFE08F30C8F}" type="datetimeFigureOut">
               <a:rPr lang="en-US" smtClean="0"/>
-              <a:t>10/24/2025</a:t>
+              <a:t>10/28/2025</a:t>
             </a:fld>
             <a:endParaRPr lang="en-US"/>
           </a:p>
@@ -1699,7 +1699,7 @@
           <a:p>
             <a:fld id="{A499D77D-9F63-495D-952D-8FFE08F30C8F}" type="datetimeFigureOut">
               <a:rPr lang="en-US" smtClean="0"/>
-              <a:t>10/24/2025</a:t>
+              <a:t>10/28/2025</a:t>
             </a:fld>
             <a:endParaRPr lang="en-US"/>
           </a:p>
@@ -1964,7 +1964,7 @@
           <a:p>
             <a:fld id="{A499D77D-9F63-495D-952D-8FFE08F30C8F}" type="datetimeFigureOut">
               <a:rPr lang="en-US" smtClean="0"/>
-              <a:t>10/24/2025</a:t>
+              <a:t>10/28/2025</a:t>
             </a:fld>
             <a:endParaRPr lang="en-US"/>
           </a:p>
@@ -2376,7 +2376,7 @@
           <a:p>
             <a:fld id="{A499D77D-9F63-495D-952D-8FFE08F30C8F}" type="datetimeFigureOut">
               <a:rPr lang="en-US" smtClean="0"/>
-              <a:t>10/24/2025</a:t>
+              <a:t>10/28/2025</a:t>
             </a:fld>
             <a:endParaRPr lang="en-US"/>
           </a:p>
@@ -2517,7 +2517,7 @@
           <a:p>
             <a:fld id="{A499D77D-9F63-495D-952D-8FFE08F30C8F}" type="datetimeFigureOut">
               <a:rPr lang="en-US" smtClean="0"/>
-              <a:t>10/24/2025</a:t>
+              <a:t>10/28/2025</a:t>
             </a:fld>
             <a:endParaRPr lang="en-US"/>
           </a:p>
@@ -2630,7 +2630,7 @@
           <a:p>
             <a:fld id="{A499D77D-9F63-495D-952D-8FFE08F30C8F}" type="datetimeFigureOut">
               <a:rPr lang="en-US" smtClean="0"/>
-              <a:t>10/24/2025</a:t>
+              <a:t>10/28/2025</a:t>
             </a:fld>
             <a:endParaRPr lang="en-US"/>
           </a:p>
@@ -2941,7 +2941,7 @@
           <a:p>
             <a:fld id="{A499D77D-9F63-495D-952D-8FFE08F30C8F}" type="datetimeFigureOut">
               <a:rPr lang="en-US" smtClean="0"/>
-              <a:t>10/24/2025</a:t>
+              <a:t>10/28/2025</a:t>
             </a:fld>
             <a:endParaRPr lang="en-US"/>
           </a:p>
@@ -3229,7 +3229,7 @@
           <a:p>
             <a:fld id="{A499D77D-9F63-495D-952D-8FFE08F30C8F}" type="datetimeFigureOut">
               <a:rPr lang="en-US" smtClean="0"/>
-              <a:t>10/24/2025</a:t>
+              <a:t>10/28/2025</a:t>
             </a:fld>
             <a:endParaRPr lang="en-US"/>
           </a:p>
@@ -3470,7 +3470,7 @@
           <a:p>
             <a:fld id="{A499D77D-9F63-495D-952D-8FFE08F30C8F}" type="datetimeFigureOut">
               <a:rPr lang="en-US" smtClean="0"/>
-              <a:t>10/24/2025</a:t>
+              <a:t>10/28/2025</a:t>
             </a:fld>
             <a:endParaRPr lang="en-US"/>
           </a:p>
@@ -8169,7 +8169,7 @@
                 <a:latin typeface="Inter" panose="02000503000000020004" pitchFamily="2" charset="0"/>
                 <a:ea typeface="Inter" panose="02000503000000020004" pitchFamily="2" charset="0"/>
               </a:rPr>
-              <a:t>Monospace green</a:t>
+              <a:t>Number Wall</a:t>
             </a:r>
           </a:p>
           <a:p>
@@ -8217,7 +8217,7 @@
                 <a:latin typeface="Inter" panose="02000503000000020004" pitchFamily="2" charset="0"/>
                 <a:ea typeface="Inter" panose="02000503000000020004" pitchFamily="2" charset="0"/>
               </a:rPr>
-              <a:t> Number Wall</a:t>
+              <a:t> Monospace Green</a:t>
             </a:r>
           </a:p>
           <a:p>
@@ -8265,7 +8265,7 @@
                 <a:latin typeface="Inter" panose="02000503000000020004" pitchFamily="2" charset="0"/>
                 <a:ea typeface="Inter" panose="02000503000000020004" pitchFamily="2" charset="0"/>
               </a:rPr>
-              <a:t> Platformer Time</a:t>
+              <a:t> Platformer Time (DVD)</a:t>
             </a:r>
           </a:p>
           <a:p>
@@ -18449,7 +18449,7 @@
                 <a:latin typeface="Inter" panose="02000503000000020004" pitchFamily="2" charset="0"/>
                 <a:ea typeface="Inter" panose="02000503000000020004" pitchFamily="2" charset="0"/>
               </a:rPr>
-              <a:t>SWAG BAG 1</a:t>
+              <a:t>SWAG BAG 2</a:t>
             </a:r>
           </a:p>
           <a:p>
@@ -18482,7 +18482,7 @@
                   </a:extLst>
                 </a:hlinkClick>
               </a:rPr>
-              <a:t>KEY D HINT 4</a:t>
+              <a:t>KEY D HINT 3</a:t>
             </a:r>
             <a:endParaRPr lang="en-US" sz="1600" dirty="0">
               <a:solidFill>
@@ -18509,7 +18509,7 @@
         <p:spPr>
           <a:xfrm>
             <a:off x="8146475" y="2698789"/>
-            <a:ext cx="3740727" cy="775082"/>
+            <a:ext cx="3740727" cy="917928"/>
           </a:xfrm>
           <a:prstGeom prst="rect">
             <a:avLst/>
@@ -18546,7 +18546,7 @@
                 <a:latin typeface="Inter" panose="02000503000000020004" pitchFamily="2" charset="0"/>
                 <a:ea typeface="Inter" panose="02000503000000020004" pitchFamily="2" charset="0"/>
               </a:rPr>
-              <a:t>SWAG BAG 2</a:t>
+              <a:t>SWAG BAG 7</a:t>
             </a:r>
           </a:p>
           <a:p>
@@ -18579,7 +18579,7 @@
                   </a:extLst>
                 </a:hlinkClick>
               </a:rPr>
-              <a:t>KEY D HINT 5</a:t>
+              <a:t>CHOSEN ONE’S KEY HINT </a:t>
             </a:r>
             <a:endParaRPr lang="en-US" sz="1600" dirty="0">
               <a:solidFill>
@@ -18605,8 +18605,8 @@
         </p:nvSpPr>
         <p:spPr>
           <a:xfrm>
-            <a:off x="8423567" y="3793831"/>
-            <a:ext cx="3011054" cy="1022077"/>
+            <a:off x="8423566" y="3793831"/>
+            <a:ext cx="3463635" cy="1022077"/>
           </a:xfrm>
           <a:prstGeom prst="rect">
             <a:avLst/>
@@ -18676,7 +18676,7 @@
                   </a:extLst>
                 </a:hlinkClick>
               </a:rPr>
-              <a:t>CHOSEN ONE’S KEY HINT</a:t>
+              <a:t>KEY D HINT 4</a:t>
             </a:r>
             <a:endParaRPr lang="en-US" sz="1600" dirty="0">
               <a:solidFill>
@@ -19704,7 +19704,7 @@
                 <a:ea typeface="Inter" panose="02000503000000020004" pitchFamily="2" charset="0"/>
                 <a:hlinkClick r:id="rId9" action="ppaction://hlinksldjump"/>
               </a:rPr>
-              <a:t>KEY D HINT 2</a:t>
+              <a:t>KEY D HINT 5</a:t>
             </a:r>
             <a:endParaRPr lang="en-US" sz="1400" dirty="0">
               <a:latin typeface="Inter" panose="02000503000000020004" pitchFamily="2" charset="0"/>
@@ -19770,7 +19770,7 @@
                 <a:ea typeface="Inter" panose="02000503000000020004" pitchFamily="2" charset="0"/>
                 <a:hlinkClick r:id="rId9" action="ppaction://hlinksldjump"/>
               </a:rPr>
-              <a:t>KEY D HINT 3</a:t>
+              <a:t>KEY D HINT 2</a:t>
             </a:r>
             <a:endParaRPr lang="en-US" sz="1400" dirty="0">
               <a:latin typeface="Inter" panose="02000503000000020004" pitchFamily="2" charset="0"/>

</xml_diff>